<commit_message>
Week 02: Brute Force algorithms
</commit_message>
<xml_diff>
--- a/Notes/4) Brute Force Approach.pptx
+++ b/Notes/4) Brute Force Approach.pptx
@@ -232,7 +232,7 @@
           <a:p>
             <a:fld id="{BB60EE8D-D51E-4102-A059-0B33F32EC08B}" type="datetimeFigureOut">
               <a:rPr lang="en-IE" smtClean="0"/>
-              <a:t>14/09/2025</a:t>
+              <a:t>23/09/2026</a:t>
             </a:fld>
             <a:endParaRPr lang="en-IE"/>
           </a:p>
@@ -554,6 +554,13 @@
             <a:schemeClr val="lt1"/>
           </a:fontRef>
         </p:style>
+        <p:txBody>
+          <a:bodyPr/>
+          <a:lstStyle/>
+          <a:p>
+            <a:endParaRPr lang="en-IE"/>
+          </a:p>
+        </p:txBody>
       </p:sp>
       <p:sp>
         <p:nvSpPr>
@@ -592,6 +599,13 @@
             <a:schemeClr val="lt1"/>
           </a:fontRef>
         </p:style>
+        <p:txBody>
+          <a:bodyPr/>
+          <a:lstStyle/>
+          <a:p>
+            <a:endParaRPr lang="en-IE"/>
+          </a:p>
+        </p:txBody>
       </p:sp>
       <p:sp>
         <p:nvSpPr>
@@ -726,7 +740,7 @@
           <a:p>
             <a:fld id="{74DF7971-A8A5-4EFB-A052-05F80CCF0C20}" type="datetimeFigureOut">
               <a:rPr lang="en-IE" smtClean="0"/>
-              <a:t>14/09/2025</a:t>
+              <a:t>23/09/2026</a:t>
             </a:fld>
             <a:endParaRPr lang="en-IE"/>
           </a:p>
@@ -934,7 +948,7 @@
           <a:p>
             <a:fld id="{74DF7971-A8A5-4EFB-A052-05F80CCF0C20}" type="datetimeFigureOut">
               <a:rPr lang="en-IE" smtClean="0"/>
-              <a:t>14/09/2025</a:t>
+              <a:t>23/09/2026</a:t>
             </a:fld>
             <a:endParaRPr lang="en-IE"/>
           </a:p>
@@ -1190,7 +1204,7 @@
           <a:p>
             <a:fld id="{74DF7971-A8A5-4EFB-A052-05F80CCF0C20}" type="datetimeFigureOut">
               <a:rPr lang="en-IE" smtClean="0"/>
-              <a:t>14/09/2025</a:t>
+              <a:t>23/09/2026</a:t>
             </a:fld>
             <a:endParaRPr lang="en-IE"/>
           </a:p>
@@ -1360,7 +1374,7 @@
           <a:p>
             <a:fld id="{74DF7971-A8A5-4EFB-A052-05F80CCF0C20}" type="datetimeFigureOut">
               <a:rPr lang="en-IE" smtClean="0"/>
-              <a:t>14/09/2025</a:t>
+              <a:t>23/09/2026</a:t>
             </a:fld>
             <a:endParaRPr lang="en-IE"/>
           </a:p>
@@ -1703,7 +1717,7 @@
           <a:p>
             <a:fld id="{74DF7971-A8A5-4EFB-A052-05F80CCF0C20}" type="datetimeFigureOut">
               <a:rPr lang="en-IE" smtClean="0"/>
-              <a:t>14/09/2025</a:t>
+              <a:t>23/09/2026</a:t>
             </a:fld>
             <a:endParaRPr lang="en-IE"/>
           </a:p>
@@ -1978,7 +1992,7 @@
           <a:p>
             <a:fld id="{74DF7971-A8A5-4EFB-A052-05F80CCF0C20}" type="datetimeFigureOut">
               <a:rPr lang="en-IE" smtClean="0"/>
-              <a:t>14/09/2025</a:t>
+              <a:t>23/09/2026</a:t>
             </a:fld>
             <a:endParaRPr lang="en-IE"/>
           </a:p>
@@ -2357,7 +2371,7 @@
           <a:p>
             <a:fld id="{74DF7971-A8A5-4EFB-A052-05F80CCF0C20}" type="datetimeFigureOut">
               <a:rPr lang="en-IE" smtClean="0"/>
-              <a:t>14/09/2025</a:t>
+              <a:t>23/09/2026</a:t>
             </a:fld>
             <a:endParaRPr lang="en-IE"/>
           </a:p>
@@ -2475,7 +2489,7 @@
           <a:p>
             <a:fld id="{74DF7971-A8A5-4EFB-A052-05F80CCF0C20}" type="datetimeFigureOut">
               <a:rPr lang="en-IE" smtClean="0"/>
-              <a:t>14/09/2025</a:t>
+              <a:t>23/09/2026</a:t>
             </a:fld>
             <a:endParaRPr lang="en-IE"/>
           </a:p>
@@ -2646,7 +2660,7 @@
           <a:p>
             <a:fld id="{74DF7971-A8A5-4EFB-A052-05F80CCF0C20}" type="datetimeFigureOut">
               <a:rPr lang="en-IE" smtClean="0"/>
-              <a:t>14/09/2025</a:t>
+              <a:t>23/09/2026</a:t>
             </a:fld>
             <a:endParaRPr lang="en-IE"/>
           </a:p>
@@ -3000,7 +3014,7 @@
           <a:p>
             <a:fld id="{74DF7971-A8A5-4EFB-A052-05F80CCF0C20}" type="datetimeFigureOut">
               <a:rPr lang="en-IE" smtClean="0"/>
-              <a:t>14/09/2025</a:t>
+              <a:t>23/09/2026</a:t>
             </a:fld>
             <a:endParaRPr lang="en-IE"/>
           </a:p>
@@ -3377,7 +3391,7 @@
           <a:p>
             <a:fld id="{74DF7971-A8A5-4EFB-A052-05F80CCF0C20}" type="datetimeFigureOut">
               <a:rPr lang="en-IE" smtClean="0"/>
-              <a:t>14/09/2025</a:t>
+              <a:t>23/09/2026</a:t>
             </a:fld>
             <a:endParaRPr lang="en-IE"/>
           </a:p>
@@ -3497,6 +3511,13 @@
             <a:schemeClr val="lt1"/>
           </a:fontRef>
         </p:style>
+        <p:txBody>
+          <a:bodyPr/>
+          <a:lstStyle/>
+          <a:p>
+            <a:endParaRPr lang="en-IE"/>
+          </a:p>
+        </p:txBody>
       </p:sp>
       <p:sp>
         <p:nvSpPr>
@@ -3535,6 +3556,13 @@
             <a:schemeClr val="lt1"/>
           </a:fontRef>
         </p:style>
+        <p:txBody>
+          <a:bodyPr/>
+          <a:lstStyle/>
+          <a:p>
+            <a:endParaRPr lang="en-IE"/>
+          </a:p>
+        </p:txBody>
       </p:sp>
       <p:sp>
         <p:nvSpPr>
@@ -3664,7 +3692,7 @@
           <a:p>
             <a:fld id="{74DF7971-A8A5-4EFB-A052-05F80CCF0C20}" type="datetimeFigureOut">
               <a:rPr lang="en-IE" smtClean="0"/>
-              <a:t>14/09/2025</a:t>
+              <a:t>23/09/2026</a:t>
             </a:fld>
             <a:endParaRPr lang="en-IE"/>
           </a:p>
@@ -4321,14 +4349,34 @@
         <p:spPr/>
         <p:txBody>
           <a:bodyPr>
-            <a:normAutofit lnSpcReduction="10000"/>
+            <a:normAutofit fontScale="85000" lnSpcReduction="20000"/>
           </a:bodyPr>
           <a:lstStyle/>
           <a:p>
             <a:pPr lvl="1"/>
             <a:r>
               <a:rPr lang="en-IE" sz="3200" dirty="0"/>
-              <a:t>This is the </a:t>
+              <a:t>A form of </a:t>
+            </a:r>
+            <a:r>
+              <a:rPr lang="en-IE" sz="3200" dirty="0">
+                <a:solidFill>
+                  <a:srgbClr val="FF0000"/>
+                </a:solidFill>
+              </a:rPr>
+              <a:t>exhaustive search </a:t>
+            </a:r>
+            <a:endParaRPr lang="en-IE" sz="3200" dirty="0"/>
+          </a:p>
+          <a:p>
+            <a:pPr lvl="1"/>
+            <a:endParaRPr lang="en-IE" sz="3200" dirty="0"/>
+          </a:p>
+          <a:p>
+            <a:pPr lvl="1"/>
+            <a:r>
+              <a:rPr lang="en-IE" sz="3200" dirty="0"/>
+              <a:t>The </a:t>
             </a:r>
             <a:r>
               <a:rPr lang="en-IE" sz="3200" dirty="0">
@@ -4340,7 +4388,7 @@
             </a:r>
             <a:r>
               <a:rPr lang="en-IE" sz="3200" dirty="0"/>
-              <a:t>approach to algorithm design by exploring every possible solution</a:t>
+              <a:t>approach to algorithm design - explore every possible solution!</a:t>
             </a:r>
           </a:p>
           <a:p>

</xml_diff>